<commit_message>
added new presentation & CV
</commit_message>
<xml_diff>
--- a/assets/img/presentation/match_size.pptx
+++ b/assets/img/presentation/match_size.pptx
@@ -262,7 +262,7 @@
           <a:p>
             <a:fld id="{8AB6B10D-0C63-4246-8458-3B1752B4C5D8}" type="datetimeFigureOut">
               <a:rPr lang="en-KR" smtClean="0"/>
-              <a:t>2020/11/04</a:t>
+              <a:t>2020/12/02</a:t>
             </a:fld>
             <a:endParaRPr lang="en-KR"/>
           </a:p>
@@ -462,7 +462,7 @@
           <a:p>
             <a:fld id="{8AB6B10D-0C63-4246-8458-3B1752B4C5D8}" type="datetimeFigureOut">
               <a:rPr lang="en-KR" smtClean="0"/>
-              <a:t>2020/11/04</a:t>
+              <a:t>2020/12/02</a:t>
             </a:fld>
             <a:endParaRPr lang="en-KR"/>
           </a:p>
@@ -672,7 +672,7 @@
           <a:p>
             <a:fld id="{8AB6B10D-0C63-4246-8458-3B1752B4C5D8}" type="datetimeFigureOut">
               <a:rPr lang="en-KR" smtClean="0"/>
-              <a:t>2020/11/04</a:t>
+              <a:t>2020/12/02</a:t>
             </a:fld>
             <a:endParaRPr lang="en-KR"/>
           </a:p>
@@ -872,7 +872,7 @@
           <a:p>
             <a:fld id="{8AB6B10D-0C63-4246-8458-3B1752B4C5D8}" type="datetimeFigureOut">
               <a:rPr lang="en-KR" smtClean="0"/>
-              <a:t>2020/11/04</a:t>
+              <a:t>2020/12/02</a:t>
             </a:fld>
             <a:endParaRPr lang="en-KR"/>
           </a:p>
@@ -1148,7 +1148,7 @@
           <a:p>
             <a:fld id="{8AB6B10D-0C63-4246-8458-3B1752B4C5D8}" type="datetimeFigureOut">
               <a:rPr lang="en-KR" smtClean="0"/>
-              <a:t>2020/11/04</a:t>
+              <a:t>2020/12/02</a:t>
             </a:fld>
             <a:endParaRPr lang="en-KR"/>
           </a:p>
@@ -1416,7 +1416,7 @@
           <a:p>
             <a:fld id="{8AB6B10D-0C63-4246-8458-3B1752B4C5D8}" type="datetimeFigureOut">
               <a:rPr lang="en-KR" smtClean="0"/>
-              <a:t>2020/11/04</a:t>
+              <a:t>2020/12/02</a:t>
             </a:fld>
             <a:endParaRPr lang="en-KR"/>
           </a:p>
@@ -1831,7 +1831,7 @@
           <a:p>
             <a:fld id="{8AB6B10D-0C63-4246-8458-3B1752B4C5D8}" type="datetimeFigureOut">
               <a:rPr lang="en-KR" smtClean="0"/>
-              <a:t>2020/11/04</a:t>
+              <a:t>2020/12/02</a:t>
             </a:fld>
             <a:endParaRPr lang="en-KR"/>
           </a:p>
@@ -1973,7 +1973,7 @@
           <a:p>
             <a:fld id="{8AB6B10D-0C63-4246-8458-3B1752B4C5D8}" type="datetimeFigureOut">
               <a:rPr lang="en-KR" smtClean="0"/>
-              <a:t>2020/11/04</a:t>
+              <a:t>2020/12/02</a:t>
             </a:fld>
             <a:endParaRPr lang="en-KR"/>
           </a:p>
@@ -2086,7 +2086,7 @@
           <a:p>
             <a:fld id="{8AB6B10D-0C63-4246-8458-3B1752B4C5D8}" type="datetimeFigureOut">
               <a:rPr lang="en-KR" smtClean="0"/>
-              <a:t>2020/11/04</a:t>
+              <a:t>2020/12/02</a:t>
             </a:fld>
             <a:endParaRPr lang="en-KR"/>
           </a:p>
@@ -2399,7 +2399,7 @@
           <a:p>
             <a:fld id="{8AB6B10D-0C63-4246-8458-3B1752B4C5D8}" type="datetimeFigureOut">
               <a:rPr lang="en-KR" smtClean="0"/>
-              <a:t>2020/11/04</a:t>
+              <a:t>2020/12/02</a:t>
             </a:fld>
             <a:endParaRPr lang="en-KR"/>
           </a:p>
@@ -2688,7 +2688,7 @@
           <a:p>
             <a:fld id="{8AB6B10D-0C63-4246-8458-3B1752B4C5D8}" type="datetimeFigureOut">
               <a:rPr lang="en-KR" smtClean="0"/>
-              <a:t>2020/11/04</a:t>
+              <a:t>2020/12/02</a:t>
             </a:fld>
             <a:endParaRPr lang="en-KR"/>
           </a:p>
@@ -2931,7 +2931,7 @@
           <a:p>
             <a:fld id="{8AB6B10D-0C63-4246-8458-3B1752B4C5D8}" type="datetimeFigureOut">
               <a:rPr lang="en-KR" smtClean="0"/>
-              <a:t>2020/11/04</a:t>
+              <a:t>2020/12/02</a:t>
             </a:fld>
             <a:endParaRPr lang="en-KR"/>
           </a:p>
@@ -3413,6 +3413,36 @@
           </a:prstGeom>
         </p:spPr>
       </p:pic>
+      <p:pic>
+        <p:nvPicPr>
+          <p:cNvPr id="3" name="Picture 2">
+            <a:extLst>
+              <a:ext uri="{FF2B5EF4-FFF2-40B4-BE49-F238E27FC236}">
+                <a16:creationId xmlns:a16="http://schemas.microsoft.com/office/drawing/2014/main" id="{C8C39007-8948-6E45-8762-CD0953BFD41C}"/>
+              </a:ext>
+            </a:extLst>
+          </p:cNvPr>
+          <p:cNvPicPr>
+            <a:picLocks noChangeAspect="1"/>
+          </p:cNvPicPr>
+          <p:nvPr/>
+        </p:nvPicPr>
+        <p:blipFill>
+          <a:blip r:embed="rId4"/>
+          <a:stretch>
+            <a:fillRect/>
+          </a:stretch>
+        </p:blipFill>
+        <p:spPr>
+          <a:xfrm>
+            <a:off x="6513814" y="2651515"/>
+            <a:ext cx="5174751" cy="2904786"/>
+          </a:xfrm>
+          <a:prstGeom prst="rect">
+            <a:avLst/>
+          </a:prstGeom>
+        </p:spPr>
+      </p:pic>
     </p:spTree>
     <p:extLst>
       <p:ext uri="{BB962C8B-B14F-4D97-AF65-F5344CB8AC3E}">
@@ -3531,7 +3561,7 @@
         </p:blipFill>
         <p:spPr>
           <a:xfrm>
-            <a:off x="523413" y="3133618"/>
+            <a:off x="5650217" y="3187380"/>
             <a:ext cx="5708650" cy="3066218"/>
           </a:xfrm>
           <a:prstGeom prst="rect">
@@ -3539,6 +3569,89 @@
           </a:prstGeom>
         </p:spPr>
       </p:pic>
+      <p:grpSp>
+        <p:nvGrpSpPr>
+          <p:cNvPr id="2" name="Group 1">
+            <a:extLst>
+              <a:ext uri="{FF2B5EF4-FFF2-40B4-BE49-F238E27FC236}">
+                <a16:creationId xmlns:a16="http://schemas.microsoft.com/office/drawing/2014/main" id="{5DB37339-90CD-F341-9743-1E9434E55C34}"/>
+              </a:ext>
+            </a:extLst>
+          </p:cNvPr>
+          <p:cNvGrpSpPr/>
+          <p:nvPr/>
+        </p:nvGrpSpPr>
+        <p:grpSpPr>
+          <a:xfrm>
+            <a:off x="377825" y="286246"/>
+            <a:ext cx="5715000" cy="4127500"/>
+            <a:chOff x="377825" y="286246"/>
+            <a:chExt cx="5715000" cy="4127500"/>
+          </a:xfrm>
+        </p:grpSpPr>
+        <p:pic>
+          <p:nvPicPr>
+            <p:cNvPr id="5" name="Picture 4">
+              <a:extLst>
+                <a:ext uri="{FF2B5EF4-FFF2-40B4-BE49-F238E27FC236}">
+                  <a16:creationId xmlns:a16="http://schemas.microsoft.com/office/drawing/2014/main" id="{B97E1878-F3A3-2142-A78F-BC612F4AC39C}"/>
+                </a:ext>
+              </a:extLst>
+            </p:cNvPr>
+            <p:cNvPicPr>
+              <a:picLocks noChangeAspect="1"/>
+            </p:cNvPicPr>
+            <p:nvPr/>
+          </p:nvPicPr>
+          <p:blipFill>
+            <a:blip r:embed="rId2"/>
+            <a:stretch>
+              <a:fillRect/>
+            </a:stretch>
+          </p:blipFill>
+          <p:spPr>
+            <a:xfrm>
+              <a:off x="377825" y="286246"/>
+              <a:ext cx="5715000" cy="4127500"/>
+            </a:xfrm>
+            <a:prstGeom prst="rect">
+              <a:avLst/>
+            </a:prstGeom>
+            <a:ln>
+              <a:noFill/>
+            </a:ln>
+          </p:spPr>
+        </p:pic>
+        <p:pic>
+          <p:nvPicPr>
+            <p:cNvPr id="8" name="Picture 7">
+              <a:extLst>
+                <a:ext uri="{FF2B5EF4-FFF2-40B4-BE49-F238E27FC236}">
+                  <a16:creationId xmlns:a16="http://schemas.microsoft.com/office/drawing/2014/main" id="{41EC494D-D0C4-5C44-8FEF-75F38685B9F5}"/>
+                </a:ext>
+              </a:extLst>
+            </p:cNvPr>
+            <p:cNvPicPr>
+              <a:picLocks noChangeAspect="1"/>
+            </p:cNvPicPr>
+            <p:nvPr/>
+          </p:nvPicPr>
+          <p:blipFill rotWithShape="1">
+            <a:blip r:embed="rId4"/>
+            <a:srcRect b="2211"/>
+            <a:stretch/>
+          </p:blipFill>
+          <p:spPr>
+            <a:xfrm>
+              <a:off x="380999" y="658164"/>
+              <a:ext cx="5711825" cy="3135360"/>
+            </a:xfrm>
+            <a:prstGeom prst="rect">
+              <a:avLst/>
+            </a:prstGeom>
+          </p:spPr>
+        </p:pic>
+      </p:grpSp>
     </p:spTree>
     <p:extLst>
       <p:ext uri="{BB962C8B-B14F-4D97-AF65-F5344CB8AC3E}">

</xml_diff>

<commit_message>
added link for trauma institute
</commit_message>
<xml_diff>
--- a/assets/img/presentation/match_size.pptx
+++ b/assets/img/presentation/match_size.pptx
@@ -262,7 +262,7 @@
           <a:p>
             <a:fld id="{8AB6B10D-0C63-4246-8458-3B1752B4C5D8}" type="datetimeFigureOut">
               <a:rPr lang="en-KR" smtClean="0"/>
-              <a:t>2020/12/02</a:t>
+              <a:t>2021/02/22</a:t>
             </a:fld>
             <a:endParaRPr lang="en-KR"/>
           </a:p>
@@ -462,7 +462,7 @@
           <a:p>
             <a:fld id="{8AB6B10D-0C63-4246-8458-3B1752B4C5D8}" type="datetimeFigureOut">
               <a:rPr lang="en-KR" smtClean="0"/>
-              <a:t>2020/12/02</a:t>
+              <a:t>2021/02/22</a:t>
             </a:fld>
             <a:endParaRPr lang="en-KR"/>
           </a:p>
@@ -672,7 +672,7 @@
           <a:p>
             <a:fld id="{8AB6B10D-0C63-4246-8458-3B1752B4C5D8}" type="datetimeFigureOut">
               <a:rPr lang="en-KR" smtClean="0"/>
-              <a:t>2020/12/02</a:t>
+              <a:t>2021/02/22</a:t>
             </a:fld>
             <a:endParaRPr lang="en-KR"/>
           </a:p>
@@ -872,7 +872,7 @@
           <a:p>
             <a:fld id="{8AB6B10D-0C63-4246-8458-3B1752B4C5D8}" type="datetimeFigureOut">
               <a:rPr lang="en-KR" smtClean="0"/>
-              <a:t>2020/12/02</a:t>
+              <a:t>2021/02/22</a:t>
             </a:fld>
             <a:endParaRPr lang="en-KR"/>
           </a:p>
@@ -1148,7 +1148,7 @@
           <a:p>
             <a:fld id="{8AB6B10D-0C63-4246-8458-3B1752B4C5D8}" type="datetimeFigureOut">
               <a:rPr lang="en-KR" smtClean="0"/>
-              <a:t>2020/12/02</a:t>
+              <a:t>2021/02/22</a:t>
             </a:fld>
             <a:endParaRPr lang="en-KR"/>
           </a:p>
@@ -1416,7 +1416,7 @@
           <a:p>
             <a:fld id="{8AB6B10D-0C63-4246-8458-3B1752B4C5D8}" type="datetimeFigureOut">
               <a:rPr lang="en-KR" smtClean="0"/>
-              <a:t>2020/12/02</a:t>
+              <a:t>2021/02/22</a:t>
             </a:fld>
             <a:endParaRPr lang="en-KR"/>
           </a:p>
@@ -1831,7 +1831,7 @@
           <a:p>
             <a:fld id="{8AB6B10D-0C63-4246-8458-3B1752B4C5D8}" type="datetimeFigureOut">
               <a:rPr lang="en-KR" smtClean="0"/>
-              <a:t>2020/12/02</a:t>
+              <a:t>2021/02/22</a:t>
             </a:fld>
             <a:endParaRPr lang="en-KR"/>
           </a:p>
@@ -1973,7 +1973,7 @@
           <a:p>
             <a:fld id="{8AB6B10D-0C63-4246-8458-3B1752B4C5D8}" type="datetimeFigureOut">
               <a:rPr lang="en-KR" smtClean="0"/>
-              <a:t>2020/12/02</a:t>
+              <a:t>2021/02/22</a:t>
             </a:fld>
             <a:endParaRPr lang="en-KR"/>
           </a:p>
@@ -2086,7 +2086,7 @@
           <a:p>
             <a:fld id="{8AB6B10D-0C63-4246-8458-3B1752B4C5D8}" type="datetimeFigureOut">
               <a:rPr lang="en-KR" smtClean="0"/>
-              <a:t>2020/12/02</a:t>
+              <a:t>2021/02/22</a:t>
             </a:fld>
             <a:endParaRPr lang="en-KR"/>
           </a:p>
@@ -2399,7 +2399,7 @@
           <a:p>
             <a:fld id="{8AB6B10D-0C63-4246-8458-3B1752B4C5D8}" type="datetimeFigureOut">
               <a:rPr lang="en-KR" smtClean="0"/>
-              <a:t>2020/12/02</a:t>
+              <a:t>2021/02/22</a:t>
             </a:fld>
             <a:endParaRPr lang="en-KR"/>
           </a:p>
@@ -2688,7 +2688,7 @@
           <a:p>
             <a:fld id="{8AB6B10D-0C63-4246-8458-3B1752B4C5D8}" type="datetimeFigureOut">
               <a:rPr lang="en-KR" smtClean="0"/>
-              <a:t>2020/12/02</a:t>
+              <a:t>2021/02/22</a:t>
             </a:fld>
             <a:endParaRPr lang="en-KR"/>
           </a:p>
@@ -2931,7 +2931,7 @@
           <a:p>
             <a:fld id="{8AB6B10D-0C63-4246-8458-3B1752B4C5D8}" type="datetimeFigureOut">
               <a:rPr lang="en-KR" smtClean="0"/>
-              <a:t>2020/12/02</a:t>
+              <a:t>2021/02/22</a:t>
             </a:fld>
             <a:endParaRPr lang="en-KR"/>
           </a:p>
@@ -3385,10 +3385,10 @@
       </p:pic>
       <p:pic>
         <p:nvPicPr>
-          <p:cNvPr id="2" name="Picture 1">
-            <a:extLst>
-              <a:ext uri="{FF2B5EF4-FFF2-40B4-BE49-F238E27FC236}">
-                <a16:creationId xmlns:a16="http://schemas.microsoft.com/office/drawing/2014/main" id="{1DA6BBE2-4C8E-E541-BB52-C74B5A043CB6}"/>
+          <p:cNvPr id="3" name="Picture 2">
+            <a:extLst>
+              <a:ext uri="{FF2B5EF4-FFF2-40B4-BE49-F238E27FC236}">
+                <a16:creationId xmlns:a16="http://schemas.microsoft.com/office/drawing/2014/main" id="{C8C39007-8948-6E45-8762-CD0953BFD41C}"/>
               </a:ext>
             </a:extLst>
           </p:cNvPr>
@@ -3405,8 +3405,8 @@
         </p:blipFill>
         <p:spPr>
           <a:xfrm>
-            <a:off x="2413858" y="821933"/>
-            <a:ext cx="5708650" cy="3066218"/>
+            <a:off x="8671388" y="3237142"/>
+            <a:ext cx="5174751" cy="2904786"/>
           </a:xfrm>
           <a:prstGeom prst="rect">
             <a:avLst/>
@@ -3415,10 +3415,10 @@
       </p:pic>
       <p:pic>
         <p:nvPicPr>
-          <p:cNvPr id="3" name="Picture 2">
-            <a:extLst>
-              <a:ext uri="{FF2B5EF4-FFF2-40B4-BE49-F238E27FC236}">
-                <a16:creationId xmlns:a16="http://schemas.microsoft.com/office/drawing/2014/main" id="{C8C39007-8948-6E45-8762-CD0953BFD41C}"/>
+          <p:cNvPr id="8" name="Picture 7">
+            <a:extLst>
+              <a:ext uri="{FF2B5EF4-FFF2-40B4-BE49-F238E27FC236}">
+                <a16:creationId xmlns:a16="http://schemas.microsoft.com/office/drawing/2014/main" id="{1E4ED8F6-42DE-E148-8EE3-AF447D8E00C3}"/>
               </a:ext>
             </a:extLst>
           </p:cNvPr>
@@ -3427,16 +3427,15 @@
           </p:cNvPicPr>
           <p:nvPr/>
         </p:nvPicPr>
-        <p:blipFill>
+        <p:blipFill rotWithShape="1">
           <a:blip r:embed="rId4"/>
-          <a:stretch>
-            <a:fillRect/>
-          </a:stretch>
+          <a:srcRect l="1552" b="1150"/>
+          <a:stretch/>
         </p:blipFill>
         <p:spPr>
           <a:xfrm>
-            <a:off x="6513814" y="2651515"/>
-            <a:ext cx="5174751" cy="2904786"/>
+            <a:off x="2406661" y="803191"/>
+            <a:ext cx="5715847" cy="3231238"/>
           </a:xfrm>
           <a:prstGeom prst="rect">
             <a:avLst/>
@@ -3475,10 +3474,10 @@
       </p:grpSpPr>
       <p:pic>
         <p:nvPicPr>
-          <p:cNvPr id="4" name="Picture 3">
-            <a:extLst>
-              <a:ext uri="{FF2B5EF4-FFF2-40B4-BE49-F238E27FC236}">
-                <a16:creationId xmlns:a16="http://schemas.microsoft.com/office/drawing/2014/main" id="{DB3376F4-992E-E245-91FB-063D16B0794A}"/>
+          <p:cNvPr id="6" name="Picture 5">
+            <a:extLst>
+              <a:ext uri="{FF2B5EF4-FFF2-40B4-BE49-F238E27FC236}">
+                <a16:creationId xmlns:a16="http://schemas.microsoft.com/office/drawing/2014/main" id="{18C323FE-4D1A-BB46-82DC-7FAB119099BE}"/>
               </a:ext>
             </a:extLst>
           </p:cNvPr>
@@ -3495,7 +3494,7 @@
         </p:blipFill>
         <p:spPr>
           <a:xfrm>
-            <a:off x="6096000" y="375600"/>
+            <a:off x="5608047" y="852653"/>
             <a:ext cx="5715000" cy="4127500"/>
           </a:xfrm>
           <a:prstGeom prst="rect">
@@ -3506,75 +3505,12 @@
           </a:ln>
         </p:spPr>
       </p:pic>
-      <p:pic>
-        <p:nvPicPr>
-          <p:cNvPr id="6" name="Picture 5">
-            <a:extLst>
-              <a:ext uri="{FF2B5EF4-FFF2-40B4-BE49-F238E27FC236}">
-                <a16:creationId xmlns:a16="http://schemas.microsoft.com/office/drawing/2014/main" id="{18C323FE-4D1A-BB46-82DC-7FAB119099BE}"/>
-              </a:ext>
-            </a:extLst>
-          </p:cNvPr>
-          <p:cNvPicPr>
-            <a:picLocks noChangeAspect="1"/>
-          </p:cNvPicPr>
-          <p:nvPr/>
-        </p:nvPicPr>
-        <p:blipFill>
-          <a:blip r:embed="rId2"/>
-          <a:stretch>
-            <a:fillRect/>
-          </a:stretch>
-        </p:blipFill>
-        <p:spPr>
-          <a:xfrm>
-            <a:off x="517063" y="2656739"/>
-            <a:ext cx="5715000" cy="4127500"/>
-          </a:xfrm>
-          <a:prstGeom prst="rect">
-            <a:avLst/>
-          </a:prstGeom>
-          <a:ln>
-            <a:noFill/>
-          </a:ln>
-        </p:spPr>
-      </p:pic>
-      <p:pic>
-        <p:nvPicPr>
-          <p:cNvPr id="7" name="Picture 6">
-            <a:extLst>
-              <a:ext uri="{FF2B5EF4-FFF2-40B4-BE49-F238E27FC236}">
-                <a16:creationId xmlns:a16="http://schemas.microsoft.com/office/drawing/2014/main" id="{BF714CAD-66BC-D449-ABFE-19A78D75A986}"/>
-              </a:ext>
-            </a:extLst>
-          </p:cNvPr>
-          <p:cNvPicPr>
-            <a:picLocks noChangeAspect="1"/>
-          </p:cNvPicPr>
-          <p:nvPr/>
-        </p:nvPicPr>
-        <p:blipFill>
-          <a:blip r:embed="rId3"/>
-          <a:stretch>
-            <a:fillRect/>
-          </a:stretch>
-        </p:blipFill>
-        <p:spPr>
-          <a:xfrm>
-            <a:off x="5650217" y="3187380"/>
-            <a:ext cx="5708650" cy="3066218"/>
-          </a:xfrm>
-          <a:prstGeom prst="rect">
-            <a:avLst/>
-          </a:prstGeom>
-        </p:spPr>
-      </p:pic>
       <p:grpSp>
         <p:nvGrpSpPr>
-          <p:cNvPr id="2" name="Group 1">
-            <a:extLst>
-              <a:ext uri="{FF2B5EF4-FFF2-40B4-BE49-F238E27FC236}">
-                <a16:creationId xmlns:a16="http://schemas.microsoft.com/office/drawing/2014/main" id="{5DB37339-90CD-F341-9743-1E9434E55C34}"/>
+          <p:cNvPr id="3" name="Group 2">
+            <a:extLst>
+              <a:ext uri="{FF2B5EF4-FFF2-40B4-BE49-F238E27FC236}">
+                <a16:creationId xmlns:a16="http://schemas.microsoft.com/office/drawing/2014/main" id="{693B92D5-8FEF-6D47-A300-D60855E4D23F}"/>
               </a:ext>
             </a:extLst>
           </p:cNvPr>
@@ -3583,18 +3519,18 @@
         </p:nvGrpSpPr>
         <p:grpSpPr>
           <a:xfrm>
-            <a:off x="377825" y="286246"/>
-            <a:ext cx="5715000" cy="4127500"/>
-            <a:chOff x="377825" y="286246"/>
-            <a:chExt cx="5715000" cy="4127500"/>
+            <a:off x="516077" y="567475"/>
+            <a:ext cx="5715847" cy="4127500"/>
+            <a:chOff x="516077" y="567475"/>
+            <a:chExt cx="5715847" cy="4127500"/>
           </a:xfrm>
         </p:grpSpPr>
         <p:pic>
           <p:nvPicPr>
-            <p:cNvPr id="5" name="Picture 4">
+            <p:cNvPr id="13" name="Picture 12">
               <a:extLst>
                 <a:ext uri="{FF2B5EF4-FFF2-40B4-BE49-F238E27FC236}">
-                  <a16:creationId xmlns:a16="http://schemas.microsoft.com/office/drawing/2014/main" id="{B97E1878-F3A3-2142-A78F-BC612F4AC39C}"/>
+                  <a16:creationId xmlns:a16="http://schemas.microsoft.com/office/drawing/2014/main" id="{4E983617-C566-1E4A-8ED1-D5A515650ACD}"/>
                 </a:ext>
               </a:extLst>
             </p:cNvPr>
@@ -3611,7 +3547,7 @@
           </p:blipFill>
           <p:spPr>
             <a:xfrm>
-              <a:off x="377825" y="286246"/>
+              <a:off x="516924" y="567475"/>
               <a:ext cx="5715000" cy="4127500"/>
             </a:xfrm>
             <a:prstGeom prst="rect">
@@ -3624,10 +3560,10 @@
         </p:pic>
         <p:pic>
           <p:nvPicPr>
-            <p:cNvPr id="8" name="Picture 7">
+            <p:cNvPr id="14" name="Picture 13">
               <a:extLst>
                 <a:ext uri="{FF2B5EF4-FFF2-40B4-BE49-F238E27FC236}">
-                  <a16:creationId xmlns:a16="http://schemas.microsoft.com/office/drawing/2014/main" id="{41EC494D-D0C4-5C44-8FEF-75F38685B9F5}"/>
+                  <a16:creationId xmlns:a16="http://schemas.microsoft.com/office/drawing/2014/main" id="{570EC970-D75F-FD4B-BBD1-945FDBEFDC02}"/>
                 </a:ext>
               </a:extLst>
             </p:cNvPr>
@@ -3637,14 +3573,14 @@
             <p:nvPr/>
           </p:nvPicPr>
           <p:blipFill rotWithShape="1">
-            <a:blip r:embed="rId4"/>
-            <a:srcRect b="2211"/>
+            <a:blip r:embed="rId3"/>
+            <a:srcRect l="1552" b="1150"/>
             <a:stretch/>
           </p:blipFill>
           <p:spPr>
             <a:xfrm>
-              <a:off x="380999" y="658164"/>
-              <a:ext cx="5711825" cy="3135360"/>
+              <a:off x="516077" y="1025612"/>
+              <a:ext cx="5715847" cy="3231238"/>
             </a:xfrm>
             <a:prstGeom prst="rect">
               <a:avLst/>

</xml_diff>